<commit_message>
Kullanım kılavuzu ve tanıtım sunumu: güncel modüllere göre revize
- Kılavuz: modül sayısı 24 → 21; Yüklenici'ye "Toplu İşlemler" (Birden
  Fazla Personel Ekle, Seçilenleri Toplu Düzenle) eklendi
- Sunum: modül sayısı 21; Merkezi Aksiyon ve Bakım Onarım çıkarıldı,
  Tabela Yönetimi eklendi; Kurul → Toplantı Yönetimi (İSG Kurulu, ÇSGB
  denetimi, konu toplantıları); Sınav Eğitim'in, Malzeme Talep KKD'nin
  içinde; 13. slayttaki Merkezi Aksiyon adımı ve ekran görüntüsü
  kaldırıldı, bağlantı çizgileri düzeltildi

Co-Authored-By: Claude Opus 5.5 <noreply@anthropic.com>
</commit_message>
<xml_diff>
--- a/tanitim/risk360-tanitim.pptx
+++ b/tanitim/risk360-tanitim.pptx
@@ -2499,7 +2499,7 @@
                 <a:ea typeface="Calibri" pitchFamily="34" charset="-122"/>
                 <a:cs typeface="Calibri" pitchFamily="34" charset="-120"/>
               </a:rPr>
-              <a:t>24 modül  ·  </a:t>
+              <a:t>21 modül  ·  </a:t>
             </a:r>
             <a:pPr indent="0" marL="0">
               <a:buNone/>
@@ -2623,7 +2623,7 @@
                 <a:ea typeface="Cambria" pitchFamily="34" charset="-122"/>
                 <a:cs typeface="Cambria" pitchFamily="34" charset="-120"/>
               </a:rPr>
-              <a:t>Ekipman, Bakım ve İzinler</a:t>
+              <a:t>Ekipman, Saha ve İzinler</a:t>
             </a:r>
             <a:endParaRPr lang="en-US" sz="2800" dirty="0"/>
           </a:p>
@@ -2662,7 +2662,7 @@
                 <a:ea typeface="Calibri" pitchFamily="34" charset="-122"/>
                 <a:cs typeface="Calibri" pitchFamily="34" charset="-120"/>
               </a:rPr>
-              <a:t>Riskli işlerin ve ekipmanların güvenli şekilde yürütülmesini sağlayan dört modül.</a:t>
+              <a:t>Ekipmanların, sahanın ve riskli işlerin güvenli şekilde yürütülmesini sağlayan dört modül.</a:t>
             </a:r>
             <a:endParaRPr lang="en-US" sz="1350" dirty="0"/>
           </a:p>
@@ -2980,7 +2980,7 @@
                 <a:ea typeface="Calibri" pitchFamily="34" charset="-122"/>
                 <a:cs typeface="Calibri" pitchFamily="34" charset="-120"/>
               </a:rPr>
-              <a:t>Zimmet, ihlal tutanağı ve satın alma öncesi saha denemesi.</a:t>
+              <a:t>Zimmet, ihlal tutanağı, satın alma öncesi saha denemesi ve malzeme talep oluru.</a:t>
             </a:r>
             <a:endParaRPr lang="en-US" sz="1150" dirty="0"/>
           </a:p>
@@ -3058,7 +3058,7 @@
                   <a:srgbClr val="000000"/>
                 </a:solidFill>
               </a:rPr>
-              <a:t>🔧</a:t>
+              <a:t>🪧</a:t>
             </a:r>
             <a:endParaRPr lang="en-US" sz="2100" dirty="0"/>
           </a:p>
@@ -3097,7 +3097,7 @@
                 <a:ea typeface="Cambria" pitchFamily="34" charset="-122"/>
                 <a:cs typeface="Cambria" pitchFamily="34" charset="-120"/>
               </a:rPr>
-              <a:t>Bakım Onarım</a:t>
+              <a:t>Tabela Yönetimi</a:t>
             </a:r>
             <a:endParaRPr lang="en-US" sz="1500" dirty="0"/>
           </a:p>
@@ -3139,7 +3139,7 @@
                 <a:ea typeface="Calibri" pitchFamily="34" charset="-122"/>
                 <a:cs typeface="Calibri" pitchFamily="34" charset="-120"/>
               </a:rPr>
-              <a:t>Arıza bildiriminden İSG onaylı kapanışa kadar tek akış.</a:t>
+              <a:t>Sahadaki İSG levhaları, eksik levha ihtiyaçları ve levha kataloğu.</a:t>
             </a:r>
             <a:endParaRPr lang="en-US" sz="1150" dirty="0"/>
           </a:p>
@@ -4131,7 +4131,7 @@
                 <a:ea typeface="Calibri" pitchFamily="34" charset="-122"/>
                 <a:cs typeface="Calibri" pitchFamily="34" charset="-120"/>
               </a:rPr>
-              <a:t>Verilen eğitimin öğrenildiğini ölçen soru bankası ve otomatik sınav üretimi.</a:t>
+              <a:t>Eğitim modülünün içinde: verilen eğitimin öğrenildiğini ölçen soru bankası ve otomatik sınav üretimi.</a:t>
             </a:r>
             <a:endParaRPr lang="en-US" sz="1150" dirty="0"/>
           </a:p>
@@ -4280,7 +4280,7 @@
                 <a:ea typeface="Calibri" pitchFamily="34" charset="-122"/>
                 <a:cs typeface="Calibri" pitchFamily="34" charset="-120"/>
               </a:rPr>
-              <a:t>İSG Kurulu toplantıları resmi tutanağa bağlanır; Uygunsuzluk (DÖF) süreci kök nedenden kapanışa kadar izlenir.</a:t>
+              <a:t>İSG Kurulu, ÇSGB denetimi ve konu toplantıları resmi tutanağa bağlanır; Uygunsuzluk (DÖF) süreci kök nedenden kapanışa kadar izlenir.</a:t>
             </a:r>
             <a:endParaRPr lang="en-US" sz="1300" dirty="0"/>
           </a:p>
@@ -4429,7 +4429,7 @@
                 <a:ea typeface="Calibri" pitchFamily="34" charset="-122"/>
                 <a:cs typeface="Calibri" pitchFamily="34" charset="-120"/>
               </a:rPr>
-              <a:t>İSG Kurulu — toplantı, karar ve imza takibi</a:t>
+              <a:t>Toplantı Yönetimi — İSG Kurulu, ÇSGB denetimi, konu toplantıları</a:t>
             </a:r>
             <a:endParaRPr lang="en-US" sz="1200" dirty="0"/>
           </a:p>
@@ -4468,7 +4468,7 @@
                 <a:ea typeface="Calibri" pitchFamily="34" charset="-122"/>
                 <a:cs typeface="Calibri" pitchFamily="34" charset="-120"/>
               </a:rPr>
-              <a:t>Uygunsuzluk (DÖF) — kök neden ve kapanış takibi</a:t>
+              <a:t>Uygunsuzluk (DÖF) — İSG ve Çevre; kök neden ve kapanış takibi</a:t>
             </a:r>
             <a:endParaRPr lang="en-US" sz="1200" dirty="0"/>
           </a:p>
@@ -4710,7 +4710,7 @@
         <p:spPr>
           <a:xfrm>
             <a:off x="3474720" y="2354580"/>
-            <a:ext cx="1508760" cy="388620"/>
+            <a:ext cx="685800" cy="388620"/>
           </a:xfrm>
           <a:prstGeom prst="line">
             <a:avLst/>
@@ -4822,7 +4822,7 @@
         <p:spPr>
           <a:xfrm>
             <a:off x="3474720" y="2354580"/>
-            <a:ext cx="1508760" cy="1348740"/>
+            <a:ext cx="685800" cy="1348740"/>
           </a:xfrm>
           <a:prstGeom prst="line">
             <a:avLst/>
@@ -4934,7 +4934,7 @@
         <p:spPr>
           <a:xfrm>
             <a:off x="3474720" y="2354580"/>
-            <a:ext cx="1508760" cy="2308860"/>
+            <a:ext cx="685800" cy="2308860"/>
           </a:xfrm>
           <a:prstGeom prst="line">
             <a:avLst/>
@@ -5039,126 +5039,14 @@
       </p:sp>
       <p:sp>
         <p:nvSpPr>
-          <p:cNvPr id="15" name="Shape 13"/>
-          <p:cNvSpPr/>
-          <p:nvPr/>
-        </p:nvSpPr>
-        <p:spPr>
-          <a:xfrm>
-            <a:off x="3474720" y="2354580"/>
-            <a:ext cx="1508760" cy="3268980"/>
-          </a:xfrm>
-          <a:prstGeom prst="line">
-            <a:avLst/>
-          </a:prstGeom>
-          <a:noFill/>
-          <a:ln w="19050">
-            <a:solidFill>
-              <a:srgbClr val="9FB3D1"/>
-            </a:solidFill>
-            <a:prstDash val="dash"/>
-          </a:ln>
-        </p:spPr>
-      </p:sp>
-      <p:sp>
-        <p:nvSpPr>
-          <p:cNvPr id="16" name="Shape 14"/>
-          <p:cNvSpPr/>
-          <p:nvPr/>
-        </p:nvSpPr>
-        <p:spPr>
-          <a:xfrm>
-            <a:off x="4160520" y="5257800"/>
-            <a:ext cx="3108960" cy="731520"/>
-          </a:xfrm>
-          <a:prstGeom prst="roundRect">
-            <a:avLst>
-              <a:gd name="adj" fmla="val 8750"/>
-            </a:avLst>
-          </a:prstGeom>
-          <a:solidFill>
-            <a:srgbClr val="0B1A33"/>
-          </a:solidFill>
-          <a:ln w="12700">
-            <a:solidFill>
-              <a:srgbClr val="2C5F8A"/>
-            </a:solidFill>
-            <a:prstDash val="solid"/>
-          </a:ln>
-        </p:spPr>
-      </p:sp>
-      <p:sp>
-        <p:nvSpPr>
-          <p:cNvPr id="17" name="Text 15"/>
-          <p:cNvSpPr txBox="1"/>
-          <p:nvPr/>
-        </p:nvSpPr>
-        <p:spPr>
-          <a:xfrm>
-            <a:off x="4297680" y="5257800"/>
-            <a:ext cx="2834640" cy="731520"/>
-          </a:xfrm>
-          <a:prstGeom prst="rect">
-            <a:avLst/>
-          </a:prstGeom>
-          <a:noFill/>
-          <a:ln/>
-        </p:spPr>
-        <p:txBody>
-          <a:bodyPr wrap="square" lIns="0" tIns="0" rIns="0" bIns="0" rtlCol="0" anchor="ctr"/>
-          <a:lstStyle/>
-          <a:p>
-            <a:pPr algn="l" indent="0" marL="0">
-              <a:lnSpc>
-                <a:spcPct val="110000"/>
-              </a:lnSpc>
-              <a:buNone/>
-            </a:pPr>
-            <a:r>
-              <a:rPr lang="en-US" sz="1150" dirty="0">
-                <a:solidFill>
-                  <a:srgbClr val="FFFFFF"/>
-                </a:solidFill>
-                <a:latin typeface="Calibri" pitchFamily="34" charset="0"/>
-                <a:ea typeface="Calibri" pitchFamily="34" charset="-122"/>
-                <a:cs typeface="Calibri" pitchFamily="34" charset="-120"/>
-              </a:rPr>
-              <a:t>📌  Merkezi Aksiyon</a:t>
-            </a:r>
-            <a:endParaRPr lang="en-US" sz="1150" dirty="0"/>
-          </a:p>
-          <a:p>
-            <a:pPr algn="l" indent="0" marL="0">
-              <a:lnSpc>
-                <a:spcPct val="110000"/>
-              </a:lnSpc>
-              <a:buNone/>
-            </a:pPr>
-            <a:r>
-              <a:rPr lang="en-US" sz="1150" dirty="0">
-                <a:solidFill>
-                  <a:srgbClr val="FFFFFF"/>
-                </a:solidFill>
-                <a:latin typeface="Calibri" pitchFamily="34" charset="0"/>
-                <a:ea typeface="Calibri" pitchFamily="34" charset="-122"/>
-                <a:cs typeface="Calibri" pitchFamily="34" charset="-120"/>
-              </a:rPr>
-              <a:t>listesinde görünür</a:t>
-            </a:r>
-            <a:endParaRPr lang="en-US" sz="1150" dirty="0"/>
-          </a:p>
-        </p:txBody>
-      </p:sp>
-      <p:sp>
-        <p:nvSpPr>
           <p:cNvPr id="18" name="Text 16"/>
           <p:cNvSpPr txBox="1"/>
           <p:nvPr/>
         </p:nvSpPr>
         <p:spPr>
           <a:xfrm>
-            <a:off x="640080" y="4160520"/>
-            <a:ext cx="4754880" cy="1417320"/>
+            <a:off x="7863840" y="2377440"/>
+            <a:ext cx="3657600" cy="2651760"/>
           </a:xfrm>
           <a:prstGeom prst="rect">
             <a:avLst/>
@@ -5177,7 +5065,7 @@
               <a:buNone/>
             </a:pPr>
             <a:r>
-              <a:rPr lang="en-US" sz="1200" dirty="0">
+              <a:rPr lang="en-US" sz="1800" dirty="0">
                 <a:solidFill>
                   <a:srgbClr val="CADCFC"/>
                 </a:solidFill>
@@ -5185,67 +5073,12 @@
                 <a:ea typeface="Calibri" pitchFamily="34" charset="-122"/>
                 <a:cs typeface="Calibri" pitchFamily="34" charset="-120"/>
               </a:rPr>
-              <a:t>Sonuç: hiçbir kayıt tek başına kalmaz, hiçbir termin unutulmaz — aşağıdaki ekran, üç ayrı modülden (Acil Durum + Uygunsuzluk) gelen açık işlerin tek listede toplandığını gösteriyor:</a:t>
-            </a:r>
-            <a:endParaRPr lang="en-US" sz="1200" dirty="0"/>
-          </a:p>
-        </p:txBody>
-      </p:sp>
-      <p:sp>
-        <p:nvSpPr>
-          <p:cNvPr id="19" name="Shape 17"/>
-          <p:cNvSpPr/>
-          <p:nvPr/>
-        </p:nvSpPr>
-        <p:spPr>
-          <a:xfrm>
-            <a:off x="5486400" y="4114800"/>
-            <a:ext cx="6126480" cy="3863340"/>
-          </a:xfrm>
-          <a:prstGeom prst="rect">
-            <a:avLst/>
-          </a:prstGeom>
-          <a:solidFill>
-            <a:srgbClr val="FFFFFF"/>
-          </a:solidFill>
-          <a:ln w="12700">
-            <a:solidFill>
-              <a:srgbClr val="D1D5DB"/>
-            </a:solidFill>
-            <a:prstDash val="solid"/>
-          </a:ln>
-          <a:effectLst>
-            <a:outerShdw sx="100000" sy="100000" kx="0" ky="0" algn="bl" rotWithShape="0" blurRad="127000" dist="50800" dir="5400000">
-              <a:srgbClr val="0B1A33">
-                <a:alpha val="35000"/>
-              </a:srgbClr>
-            </a:outerShdw>
-          </a:effectLst>
-        </p:spPr>
-      </p:sp>
-      <p:pic>
-        <p:nvPicPr>
-          <p:cNvPr id="20" name="Image 0" descr="/tmp/claude-0/-home-user-risk361/f13354e1-b2cc-52ad-9c31-b8bd883bf31d/scratchpad/pptx/shots/09-merkezi-aksiyon.jpg">    </p:cNvPr>
-          <p:cNvPicPr>
-            <a:picLocks noChangeAspect="1"/>
-          </p:cNvPicPr>
-          <p:nvPr/>
-        </p:nvPicPr>
-        <p:blipFill>
-          <a:blip r:embed="rId1"/>
-          <a:srcRect l="0" r="0" t="0" b="0"/>
-          <a:stretch/>
-        </p:blipFill>
-        <p:spPr>
-          <a:xfrm>
-            <a:off x="5532120" y="4160520"/>
-            <a:ext cx="6035040" cy="3771900"/>
-          </a:xfrm>
-          <a:prstGeom prst="rect">
-            <a:avLst/>
-          </a:prstGeom>
-        </p:spPr>
-      </p:pic>
+              <a:t>Sonuç: hiçbir kayıt tek başına kalmaz, hiçbir termin unutulmaz.</a:t>
+            </a:r>
+            <a:endParaRPr lang="en-US" sz="1800" dirty="0"/>
+          </a:p>
+        </p:txBody>
+      </p:sp>
       <p:sp>
         <p:nvSpPr>
           <p:cNvPr id="21" name="Text 18"/>
@@ -5908,7 +5741,7 @@
                 <a:ea typeface="Calibri" pitchFamily="34" charset="-122"/>
                 <a:cs typeface="Calibri" pitchFamily="34" charset="-120"/>
               </a:rPr>
-              <a:t>Toplu içe/dışa aktarım şablonları, merkezi aksiyon listesi, sicil özeti...</a:t>
+              <a:t>Toplu içe/dışa aktarım şablonları, sicil özeti, kayıt dökümleri...</a:t>
             </a:r>
             <a:endParaRPr lang="en-US" sz="1050" dirty="0"/>
           </a:p>
@@ -6233,7 +6066,7 @@
                 <a:ea typeface="Calibri" pitchFamily="34" charset="-122"/>
                 <a:cs typeface="Calibri" pitchFamily="34" charset="-120"/>
               </a:rPr>
-              <a:t>Ana panelin en üstündeki "📖 Kullanım Kılavuzu" butonuyla açılan sayfa, 24 modülün her birini kim, ne, nasıl girer / hangi raporlar çıkar / hangi modülle bağlantılıdır sorularıyla anlatır. Uygulamayı hiç görmemiş bir çalışan bile tek başına okuyup öğrenebilir.</a:t>
+              <a:t>Ana panelin en üstündeki "📖 Kullanım Kılavuzu" butonuyla açılan sayfa, 21 modülün her birini kim, ne, nasıl girer / hangi raporlar çıkar / hangi modülle bağlantılıdır sorularıyla anlatır. Uygulamayı hiç görmemiş bir çalışan bile tek başına okuyup öğrenebilir.</a:t>
             </a:r>
             <a:endParaRPr lang="en-US" sz="1250" dirty="0"/>
           </a:p>
@@ -8033,7 +7866,7 @@
                 <a:ea typeface="Cambria" pitchFamily="34" charset="-122"/>
                 <a:cs typeface="Cambria" pitchFamily="34" charset="-120"/>
               </a:rPr>
-              <a:t>birbirine bağlı 24 modül</a:t>
+              <a:t>birbirine bağlı 21 modül</a:t>
             </a:r>
             <a:endParaRPr lang="en-US" sz="3200" dirty="0"/>
           </a:p>
@@ -8114,7 +7947,7 @@
                 <a:ea typeface="Cambria" pitchFamily="34" charset="-122"/>
                 <a:cs typeface="Cambria" pitchFamily="34" charset="-120"/>
               </a:rPr>
-              <a:t>24</a:t>
+              <a:t>21</a:t>
             </a:r>
             <a:endParaRPr lang="en-US" sz="3400" dirty="0"/>
           </a:p>
@@ -9423,7 +9256,7 @@
                 <a:ea typeface="Cambria" pitchFamily="34" charset="-122"/>
                 <a:cs typeface="Cambria" pitchFamily="34" charset="-120"/>
               </a:rPr>
-              <a:t>24 modül, 6 ana başlıkta toplanır</a:t>
+              <a:t>21 modül, 6 ana başlıkta toplanır</a:t>
             </a:r>
             <a:endParaRPr lang="en-US" sz="2800" dirty="0"/>
           </a:p>
@@ -9562,7 +9395,7 @@
                 <a:ea typeface="Calibri" pitchFamily="34" charset="-122"/>
                 <a:cs typeface="Calibri" pitchFamily="34" charset="-120"/>
               </a:rPr>
-              <a:t>Personel · Eğitim · Yıllık Plan</a:t>
+              <a:t>Personel · Eğitim ve Sınav · Yıllık Plan</a:t>
             </a:r>
             <a:endParaRPr lang="en-US" sz="1100" dirty="0"/>
           </a:p>
@@ -9937,7 +9770,7 @@
                 <a:ea typeface="Cambria" pitchFamily="34" charset="-122"/>
                 <a:cs typeface="Cambria" pitchFamily="34" charset="-120"/>
               </a:rPr>
-              <a:t>Ekipman, Bakım ve İzinler</a:t>
+              <a:t>Ekipman, Saha ve İzinler</a:t>
             </a:r>
             <a:endParaRPr lang="en-US" sz="1500" dirty="0"/>
           </a:p>
@@ -9979,7 +9812,7 @@
                 <a:ea typeface="Calibri" pitchFamily="34" charset="-122"/>
                 <a:cs typeface="Calibri" pitchFamily="34" charset="-120"/>
               </a:rPr>
-              <a:t>Periyodik Kontrol · KKD · Bakım Onarım · İş İzinleri</a:t>
+              <a:t>Periyodik Kontrol · KKD · İş İzinleri · Tabela</a:t>
             </a:r>
             <a:endParaRPr lang="en-US" sz="1100" dirty="0"/>
           </a:p>
@@ -10118,7 +9951,7 @@
                 <a:ea typeface="Calibri" pitchFamily="34" charset="-122"/>
                 <a:cs typeface="Calibri" pitchFamily="34" charset="-120"/>
               </a:rPr>
-              <a:t>Staj · Yüklenici · Hizmet Sözleşmesi · Sınav</a:t>
+              <a:t>Staj · Yüklenici · Hizmet Sözleşmesi</a:t>
             </a:r>
             <a:endParaRPr lang="en-US" sz="1100" dirty="0"/>
           </a:p>
@@ -10257,7 +10090,7 @@
                 <a:ea typeface="Calibri" pitchFamily="34" charset="-122"/>
                 <a:cs typeface="Calibri" pitchFamily="34" charset="-120"/>
               </a:rPr>
-              <a:t>Kurul · Merkezi Aksiyon · Raporlar · Harita · Malzeme Talep</a:t>
+              <a:t>Toplantı Yönetimi · Raporlar · Harita</a:t>
             </a:r>
             <a:endParaRPr lang="en-US" sz="1100" dirty="0"/>
           </a:p>

</xml_diff>